<commit_message>
Update resources/copyright_form.docx and other recent changes
</commit_message>
<xml_diff>
--- a/resources/presentation_slide.pptx
+++ b/resources/presentation_slide.pptx
@@ -1,35 +1,36 @@
 
 <file path=ppt/presentation.xml><?xml version="1.0" encoding="utf-8"?>
-<p:presentation xmlns:a="http://schemas.openxmlformats.org/drawingml/2006/main" xmlns:r="http://schemas.openxmlformats.org/officeDocument/2006/relationships" xmlns:p="http://schemas.openxmlformats.org/presentationml/2006/main" saveSubsetFonts="1" embedTrueTypeFonts="true">
+<p:presentation xmlns:a="http://schemas.openxmlformats.org/drawingml/2006/main" xmlns:r="http://schemas.openxmlformats.org/officeDocument/2006/relationships" xmlns:p="http://schemas.openxmlformats.org/presentationml/2006/main" embedTrueTypeFonts="1" saveSubsetFonts="1">
   <p:sldMasterIdLst>
     <p:sldMasterId id="2147483648" r:id="rId1"/>
   </p:sldMasterIdLst>
   <p:sldIdLst>
-    <p:sldId id="256" r:id="rId6"/>
-    <p:sldId id="257" r:id="rId7"/>
+    <p:sldId id="256" r:id="rId2"/>
+    <p:sldId id="257" r:id="rId3"/>
   </p:sldIdLst>
   <p:sldSz cx="18288000" cy="10287000"/>
   <p:notesSz cx="6858000" cy="9144000"/>
   <p:embeddedFontLst>
     <p:embeddedFont>
-      <p:font typeface="Aptos Bold" charset="1" panose="020B0004020202020204"/>
-      <p:regular r:id="rId8"/>
+      <p:font typeface="Aptos Bold" panose="020B0604020202020204" charset="0"/>
+      <p:regular r:id="rId4"/>
     </p:embeddedFont>
     <p:embeddedFont>
-      <p:font typeface="Calibri (MS) Bold" charset="1" panose="020F0702030404030204"/>
-      <p:regular r:id="rId9"/>
+      <p:font typeface="Aptos Bold Italics" panose="020B0604020202020204" charset="0"/>
+      <p:regular r:id="rId5"/>
     </p:embeddedFont>
     <p:embeddedFont>
-      <p:font typeface="Aptos Bold Italics" charset="1" panose="020B0004020202090204"/>
-      <p:regular r:id="rId10"/>
+      <p:font typeface="Calibri (MS) Bold" panose="020B0604020202020204" charset="0"/>
+      <p:regular r:id="rId6"/>
     </p:embeddedFont>
     <p:embeddedFont>
-      <p:font typeface="Times New Roman Bold" charset="1" panose="02020803070505020304"/>
-      <p:regular r:id="rId11"/>
+      <p:font typeface="Times New Roman Bold" panose="02020803070505020304" pitchFamily="18" charset="0"/>
+      <p:regular r:id="rId7"/>
+      <p:bold r:id="rId8"/>
     </p:embeddedFont>
     <p:embeddedFont>
-      <p:font typeface="Times New Roman Bold Italics" charset="1" panose="02020703060505090304"/>
-      <p:regular r:id="rId12"/>
+      <p:font typeface="Times New Roman Bold Italics" panose="020B0604020202020204" charset="0"/>
+      <p:regular r:id="rId9"/>
     </p:embeddedFont>
   </p:embeddedFontLst>
   <p:defaultTextStyle>
@@ -127,6 +128,22 @@
       </a:defRPr>
     </a:lvl9pPr>
   </p:defaultTextStyle>
+  <p:extLst>
+    <p:ext uri="{EFAFB233-063F-42B5-8137-9DF3F51BA10A}">
+      <p15:sldGuideLst xmlns:p15="http://schemas.microsoft.com/office/powerpoint/2012/main">
+        <p15:guide id="1" orient="horz" pos="2160">
+          <p15:clr>
+            <a:srgbClr val="A4A3A4"/>
+          </p15:clr>
+        </p15:guide>
+        <p15:guide id="2" pos="2880">
+          <p15:clr>
+            <a:srgbClr val="A4A3A4"/>
+          </p15:clr>
+        </p15:guide>
+      </p15:sldGuideLst>
+    </p:ext>
+  </p:extLst>
 </p:presentation>
 </file>
 
@@ -168,10 +185,9 @@
           <a:lstStyle/>
           <a:p>
             <a:r>
-              <a:rPr lang="en-US" smtClean="0"/>
+              <a:rPr lang="en-US"/>
               <a:t>Click to edit Master title style</a:t>
             </a:r>
-            <a:endParaRPr lang="en-US"/>
           </a:p>
         </p:txBody>
       </p:sp>
@@ -287,10 +303,9 @@
           </a:lstStyle>
           <a:p>
             <a:r>
-              <a:rPr lang="en-US" smtClean="0"/>
+              <a:rPr lang="en-US"/>
               <a:t>Click to edit Master subtitle style</a:t>
             </a:r>
-            <a:endParaRPr lang="en-US"/>
           </a:p>
         </p:txBody>
       </p:sp>
@@ -312,7 +327,7 @@
             <a:fld id="{1D8BD707-D9CF-40AE-B4C6-C98DA3205C09}" type="datetimeFigureOut">
               <a:rPr lang="en-US" smtClean="0"/>
               <a:pPr/>
-              <a:t>8/1/2011</a:t>
+              <a:t>4/7/2026</a:t>
             </a:fld>
             <a:endParaRPr lang="en-US"/>
           </a:p>
@@ -402,10 +417,9 @@
           <a:lstStyle/>
           <a:p>
             <a:r>
-              <a:rPr lang="en-US" smtClean="0"/>
+              <a:rPr lang="en-US"/>
               <a:t>Click to edit Master title style</a:t>
             </a:r>
-            <a:endParaRPr lang="en-US"/>
           </a:p>
         </p:txBody>
       </p:sp>
@@ -426,38 +440,37 @@
           <a:p>
             <a:pPr lvl="0"/>
             <a:r>
-              <a:rPr lang="en-US" smtClean="0"/>
+              <a:rPr lang="en-US"/>
               <a:t>Click to edit Master text styles</a:t>
             </a:r>
           </a:p>
           <a:p>
             <a:pPr lvl="1"/>
             <a:r>
-              <a:rPr lang="en-US" smtClean="0"/>
+              <a:rPr lang="en-US"/>
               <a:t>Second level</a:t>
             </a:r>
           </a:p>
           <a:p>
             <a:pPr lvl="2"/>
             <a:r>
-              <a:rPr lang="en-US" smtClean="0"/>
+              <a:rPr lang="en-US"/>
               <a:t>Third level</a:t>
             </a:r>
           </a:p>
           <a:p>
             <a:pPr lvl="3"/>
             <a:r>
-              <a:rPr lang="en-US" smtClean="0"/>
+              <a:rPr lang="en-US"/>
               <a:t>Fourth level</a:t>
             </a:r>
           </a:p>
           <a:p>
             <a:pPr lvl="4"/>
             <a:r>
-              <a:rPr lang="en-US" smtClean="0"/>
+              <a:rPr lang="en-US"/>
               <a:t>Fifth level</a:t>
             </a:r>
-            <a:endParaRPr lang="en-US"/>
           </a:p>
         </p:txBody>
       </p:sp>
@@ -479,7 +492,7 @@
             <a:fld id="{1D8BD707-D9CF-40AE-B4C6-C98DA3205C09}" type="datetimeFigureOut">
               <a:rPr lang="en-US" smtClean="0"/>
               <a:pPr/>
-              <a:t>8/1/2011</a:t>
+              <a:t>4/7/2026</a:t>
             </a:fld>
             <a:endParaRPr lang="en-US"/>
           </a:p>
@@ -574,10 +587,9 @@
           <a:lstStyle/>
           <a:p>
             <a:r>
-              <a:rPr lang="en-US" smtClean="0"/>
+              <a:rPr lang="en-US"/>
               <a:t>Click to edit Master title style</a:t>
             </a:r>
-            <a:endParaRPr lang="en-US"/>
           </a:p>
         </p:txBody>
       </p:sp>
@@ -603,38 +615,37 @@
           <a:p>
             <a:pPr lvl="0"/>
             <a:r>
-              <a:rPr lang="en-US" smtClean="0"/>
+              <a:rPr lang="en-US"/>
               <a:t>Click to edit Master text styles</a:t>
             </a:r>
           </a:p>
           <a:p>
             <a:pPr lvl="1"/>
             <a:r>
-              <a:rPr lang="en-US" smtClean="0"/>
+              <a:rPr lang="en-US"/>
               <a:t>Second level</a:t>
             </a:r>
           </a:p>
           <a:p>
             <a:pPr lvl="2"/>
             <a:r>
-              <a:rPr lang="en-US" smtClean="0"/>
+              <a:rPr lang="en-US"/>
               <a:t>Third level</a:t>
             </a:r>
           </a:p>
           <a:p>
             <a:pPr lvl="3"/>
             <a:r>
-              <a:rPr lang="en-US" smtClean="0"/>
+              <a:rPr lang="en-US"/>
               <a:t>Fourth level</a:t>
             </a:r>
           </a:p>
           <a:p>
             <a:pPr lvl="4"/>
             <a:r>
-              <a:rPr lang="en-US" smtClean="0"/>
+              <a:rPr lang="en-US"/>
               <a:t>Fifth level</a:t>
             </a:r>
-            <a:endParaRPr lang="en-US"/>
           </a:p>
         </p:txBody>
       </p:sp>
@@ -656,7 +667,7 @@
             <a:fld id="{1D8BD707-D9CF-40AE-B4C6-C98DA3205C09}" type="datetimeFigureOut">
               <a:rPr lang="en-US" smtClean="0"/>
               <a:pPr/>
-              <a:t>8/1/2011</a:t>
+              <a:t>4/7/2026</a:t>
             </a:fld>
             <a:endParaRPr lang="en-US"/>
           </a:p>
@@ -746,10 +757,9 @@
           <a:lstStyle/>
           <a:p>
             <a:r>
-              <a:rPr lang="en-US" smtClean="0"/>
+              <a:rPr lang="en-US"/>
               <a:t>Click to edit Master title style</a:t>
             </a:r>
-            <a:endParaRPr lang="en-US"/>
           </a:p>
         </p:txBody>
       </p:sp>
@@ -770,38 +780,37 @@
           <a:p>
             <a:pPr lvl="0"/>
             <a:r>
-              <a:rPr lang="en-US" smtClean="0"/>
+              <a:rPr lang="en-US"/>
               <a:t>Click to edit Master text styles</a:t>
             </a:r>
           </a:p>
           <a:p>
             <a:pPr lvl="1"/>
             <a:r>
-              <a:rPr lang="en-US" smtClean="0"/>
+              <a:rPr lang="en-US"/>
               <a:t>Second level</a:t>
             </a:r>
           </a:p>
           <a:p>
             <a:pPr lvl="2"/>
             <a:r>
-              <a:rPr lang="en-US" smtClean="0"/>
+              <a:rPr lang="en-US"/>
               <a:t>Third level</a:t>
             </a:r>
           </a:p>
           <a:p>
             <a:pPr lvl="3"/>
             <a:r>
-              <a:rPr lang="en-US" smtClean="0"/>
+              <a:rPr lang="en-US"/>
               <a:t>Fourth level</a:t>
             </a:r>
           </a:p>
           <a:p>
             <a:pPr lvl="4"/>
             <a:r>
-              <a:rPr lang="en-US" smtClean="0"/>
+              <a:rPr lang="en-US"/>
               <a:t>Fifth level</a:t>
             </a:r>
-            <a:endParaRPr lang="en-US"/>
           </a:p>
         </p:txBody>
       </p:sp>
@@ -823,7 +832,7 @@
             <a:fld id="{1D8BD707-D9CF-40AE-B4C6-C98DA3205C09}" type="datetimeFigureOut">
               <a:rPr lang="en-US" smtClean="0"/>
               <a:pPr/>
-              <a:t>8/1/2011</a:t>
+              <a:t>4/7/2026</a:t>
             </a:fld>
             <a:endParaRPr lang="en-US"/>
           </a:p>
@@ -922,10 +931,9 @@
           </a:lstStyle>
           <a:p>
             <a:r>
-              <a:rPr lang="en-US" smtClean="0"/>
+              <a:rPr lang="en-US"/>
               <a:t>Click to edit Master title style</a:t>
             </a:r>
-            <a:endParaRPr lang="en-US"/>
           </a:p>
         </p:txBody>
       </p:sp>
@@ -1042,7 +1050,7 @@
           <a:p>
             <a:pPr lvl="0"/>
             <a:r>
-              <a:rPr lang="en-US" smtClean="0"/>
+              <a:rPr lang="en-US"/>
               <a:t>Click to edit Master text styles</a:t>
             </a:r>
           </a:p>
@@ -1066,7 +1074,7 @@
             <a:fld id="{1D8BD707-D9CF-40AE-B4C6-C98DA3205C09}" type="datetimeFigureOut">
               <a:rPr lang="en-US" smtClean="0"/>
               <a:pPr/>
-              <a:t>8/1/2011</a:t>
+              <a:t>4/7/2026</a:t>
             </a:fld>
             <a:endParaRPr lang="en-US"/>
           </a:p>
@@ -1156,10 +1164,9 @@
           <a:lstStyle/>
           <a:p>
             <a:r>
-              <a:rPr lang="en-US" smtClean="0"/>
+              <a:rPr lang="en-US"/>
               <a:t>Click to edit Master title style</a:t>
             </a:r>
-            <a:endParaRPr lang="en-US"/>
           </a:p>
         </p:txBody>
       </p:sp>
@@ -1213,38 +1220,37 @@
           <a:p>
             <a:pPr lvl="0"/>
             <a:r>
-              <a:rPr lang="en-US" smtClean="0"/>
+              <a:rPr lang="en-US"/>
               <a:t>Click to edit Master text styles</a:t>
             </a:r>
           </a:p>
           <a:p>
             <a:pPr lvl="1"/>
             <a:r>
-              <a:rPr lang="en-US" smtClean="0"/>
+              <a:rPr lang="en-US"/>
               <a:t>Second level</a:t>
             </a:r>
           </a:p>
           <a:p>
             <a:pPr lvl="2"/>
             <a:r>
-              <a:rPr lang="en-US" smtClean="0"/>
+              <a:rPr lang="en-US"/>
               <a:t>Third level</a:t>
             </a:r>
           </a:p>
           <a:p>
             <a:pPr lvl="3"/>
             <a:r>
-              <a:rPr lang="en-US" smtClean="0"/>
+              <a:rPr lang="en-US"/>
               <a:t>Fourth level</a:t>
             </a:r>
           </a:p>
           <a:p>
             <a:pPr lvl="4"/>
             <a:r>
-              <a:rPr lang="en-US" smtClean="0"/>
+              <a:rPr lang="en-US"/>
               <a:t>Fifth level</a:t>
             </a:r>
-            <a:endParaRPr lang="en-US"/>
           </a:p>
         </p:txBody>
       </p:sp>
@@ -1298,38 +1304,37 @@
           <a:p>
             <a:pPr lvl="0"/>
             <a:r>
-              <a:rPr lang="en-US" smtClean="0"/>
+              <a:rPr lang="en-US"/>
               <a:t>Click to edit Master text styles</a:t>
             </a:r>
           </a:p>
           <a:p>
             <a:pPr lvl="1"/>
             <a:r>
-              <a:rPr lang="en-US" smtClean="0"/>
+              <a:rPr lang="en-US"/>
               <a:t>Second level</a:t>
             </a:r>
           </a:p>
           <a:p>
             <a:pPr lvl="2"/>
             <a:r>
-              <a:rPr lang="en-US" smtClean="0"/>
+              <a:rPr lang="en-US"/>
               <a:t>Third level</a:t>
             </a:r>
           </a:p>
           <a:p>
             <a:pPr lvl="3"/>
             <a:r>
-              <a:rPr lang="en-US" smtClean="0"/>
+              <a:rPr lang="en-US"/>
               <a:t>Fourth level</a:t>
             </a:r>
           </a:p>
           <a:p>
             <a:pPr lvl="4"/>
             <a:r>
-              <a:rPr lang="en-US" smtClean="0"/>
+              <a:rPr lang="en-US"/>
               <a:t>Fifth level</a:t>
             </a:r>
-            <a:endParaRPr lang="en-US"/>
           </a:p>
         </p:txBody>
       </p:sp>
@@ -1351,7 +1356,7 @@
             <a:fld id="{1D8BD707-D9CF-40AE-B4C6-C98DA3205C09}" type="datetimeFigureOut">
               <a:rPr lang="en-US" smtClean="0"/>
               <a:pPr/>
-              <a:t>8/1/2011</a:t>
+              <a:t>4/7/2026</a:t>
             </a:fld>
             <a:endParaRPr lang="en-US"/>
           </a:p>
@@ -1445,10 +1450,9 @@
           </a:lstStyle>
           <a:p>
             <a:r>
-              <a:rPr lang="en-US" smtClean="0"/>
+              <a:rPr lang="en-US"/>
               <a:t>Click to edit Master title style</a:t>
             </a:r>
-            <a:endParaRPr lang="en-US"/>
           </a:p>
         </p:txBody>
       </p:sp>
@@ -1511,7 +1515,7 @@
           <a:p>
             <a:pPr lvl="0"/>
             <a:r>
-              <a:rPr lang="en-US" smtClean="0"/>
+              <a:rPr lang="en-US"/>
               <a:t>Click to edit Master text styles</a:t>
             </a:r>
           </a:p>
@@ -1567,38 +1571,37 @@
           <a:p>
             <a:pPr lvl="0"/>
             <a:r>
-              <a:rPr lang="en-US" smtClean="0"/>
+              <a:rPr lang="en-US"/>
               <a:t>Click to edit Master text styles</a:t>
             </a:r>
           </a:p>
           <a:p>
             <a:pPr lvl="1"/>
             <a:r>
-              <a:rPr lang="en-US" smtClean="0"/>
+              <a:rPr lang="en-US"/>
               <a:t>Second level</a:t>
             </a:r>
           </a:p>
           <a:p>
             <a:pPr lvl="2"/>
             <a:r>
-              <a:rPr lang="en-US" smtClean="0"/>
+              <a:rPr lang="en-US"/>
               <a:t>Third level</a:t>
             </a:r>
           </a:p>
           <a:p>
             <a:pPr lvl="3"/>
             <a:r>
-              <a:rPr lang="en-US" smtClean="0"/>
+              <a:rPr lang="en-US"/>
               <a:t>Fourth level</a:t>
             </a:r>
           </a:p>
           <a:p>
             <a:pPr lvl="4"/>
             <a:r>
-              <a:rPr lang="en-US" smtClean="0"/>
+              <a:rPr lang="en-US"/>
               <a:t>Fifth level</a:t>
             </a:r>
-            <a:endParaRPr lang="en-US"/>
           </a:p>
         </p:txBody>
       </p:sp>
@@ -1661,7 +1664,7 @@
           <a:p>
             <a:pPr lvl="0"/>
             <a:r>
-              <a:rPr lang="en-US" smtClean="0"/>
+              <a:rPr lang="en-US"/>
               <a:t>Click to edit Master text styles</a:t>
             </a:r>
           </a:p>
@@ -1717,38 +1720,37 @@
           <a:p>
             <a:pPr lvl="0"/>
             <a:r>
-              <a:rPr lang="en-US" smtClean="0"/>
+              <a:rPr lang="en-US"/>
               <a:t>Click to edit Master text styles</a:t>
             </a:r>
           </a:p>
           <a:p>
             <a:pPr lvl="1"/>
             <a:r>
-              <a:rPr lang="en-US" smtClean="0"/>
+              <a:rPr lang="en-US"/>
               <a:t>Second level</a:t>
             </a:r>
           </a:p>
           <a:p>
             <a:pPr lvl="2"/>
             <a:r>
-              <a:rPr lang="en-US" smtClean="0"/>
+              <a:rPr lang="en-US"/>
               <a:t>Third level</a:t>
             </a:r>
           </a:p>
           <a:p>
             <a:pPr lvl="3"/>
             <a:r>
-              <a:rPr lang="en-US" smtClean="0"/>
+              <a:rPr lang="en-US"/>
               <a:t>Fourth level</a:t>
             </a:r>
           </a:p>
           <a:p>
             <a:pPr lvl="4"/>
             <a:r>
-              <a:rPr lang="en-US" smtClean="0"/>
+              <a:rPr lang="en-US"/>
               <a:t>Fifth level</a:t>
             </a:r>
-            <a:endParaRPr lang="en-US"/>
           </a:p>
         </p:txBody>
       </p:sp>
@@ -1770,7 +1772,7 @@
             <a:fld id="{1D8BD707-D9CF-40AE-B4C6-C98DA3205C09}" type="datetimeFigureOut">
               <a:rPr lang="en-US" smtClean="0"/>
               <a:pPr/>
-              <a:t>8/1/2011</a:t>
+              <a:t>4/7/2026</a:t>
             </a:fld>
             <a:endParaRPr lang="en-US"/>
           </a:p>
@@ -1860,10 +1862,9 @@
           <a:lstStyle/>
           <a:p>
             <a:r>
-              <a:rPr lang="en-US" smtClean="0"/>
+              <a:rPr lang="en-US"/>
               <a:t>Click to edit Master title style</a:t>
             </a:r>
-            <a:endParaRPr lang="en-US"/>
           </a:p>
         </p:txBody>
       </p:sp>
@@ -1885,7 +1886,7 @@
             <a:fld id="{1D8BD707-D9CF-40AE-B4C6-C98DA3205C09}" type="datetimeFigureOut">
               <a:rPr lang="en-US" smtClean="0"/>
               <a:pPr/>
-              <a:t>8/1/2011</a:t>
+              <a:t>4/7/2026</a:t>
             </a:fld>
             <a:endParaRPr lang="en-US"/>
           </a:p>
@@ -1977,7 +1978,7 @@
             <a:fld id="{1D8BD707-D9CF-40AE-B4C6-C98DA3205C09}" type="datetimeFigureOut">
               <a:rPr lang="en-US" smtClean="0"/>
               <a:pPr/>
-              <a:t>8/1/2011</a:t>
+              <a:t>4/7/2026</a:t>
             </a:fld>
             <a:endParaRPr lang="en-US"/>
           </a:p>
@@ -2076,10 +2077,9 @@
           </a:lstStyle>
           <a:p>
             <a:r>
-              <a:rPr lang="en-US" smtClean="0"/>
+              <a:rPr lang="en-US"/>
               <a:t>Click to edit Master title style</a:t>
             </a:r>
-            <a:endParaRPr lang="en-US"/>
           </a:p>
         </p:txBody>
       </p:sp>
@@ -2133,38 +2133,37 @@
           <a:p>
             <a:pPr lvl="0"/>
             <a:r>
-              <a:rPr lang="en-US" smtClean="0"/>
+              <a:rPr lang="en-US"/>
               <a:t>Click to edit Master text styles</a:t>
             </a:r>
           </a:p>
           <a:p>
             <a:pPr lvl="1"/>
             <a:r>
-              <a:rPr lang="en-US" smtClean="0"/>
+              <a:rPr lang="en-US"/>
               <a:t>Second level</a:t>
             </a:r>
           </a:p>
           <a:p>
             <a:pPr lvl="2"/>
             <a:r>
-              <a:rPr lang="en-US" smtClean="0"/>
+              <a:rPr lang="en-US"/>
               <a:t>Third level</a:t>
             </a:r>
           </a:p>
           <a:p>
             <a:pPr lvl="3"/>
             <a:r>
-              <a:rPr lang="en-US" smtClean="0"/>
+              <a:rPr lang="en-US"/>
               <a:t>Fourth level</a:t>
             </a:r>
           </a:p>
           <a:p>
             <a:pPr lvl="4"/>
             <a:r>
-              <a:rPr lang="en-US" smtClean="0"/>
+              <a:rPr lang="en-US"/>
               <a:t>Fifth level</a:t>
             </a:r>
-            <a:endParaRPr lang="en-US"/>
           </a:p>
         </p:txBody>
       </p:sp>
@@ -2227,7 +2226,7 @@
           <a:p>
             <a:pPr lvl="0"/>
             <a:r>
-              <a:rPr lang="en-US" smtClean="0"/>
+              <a:rPr lang="en-US"/>
               <a:t>Click to edit Master text styles</a:t>
             </a:r>
           </a:p>
@@ -2251,7 +2250,7 @@
             <a:fld id="{1D8BD707-D9CF-40AE-B4C6-C98DA3205C09}" type="datetimeFigureOut">
               <a:rPr lang="en-US" smtClean="0"/>
               <a:pPr/>
-              <a:t>8/1/2011</a:t>
+              <a:t>4/7/2026</a:t>
             </a:fld>
             <a:endParaRPr lang="en-US"/>
           </a:p>
@@ -2350,10 +2349,9 @@
           </a:lstStyle>
           <a:p>
             <a:r>
-              <a:rPr lang="en-US" smtClean="0"/>
+              <a:rPr lang="en-US"/>
               <a:t>Click to edit Master title style</a:t>
             </a:r>
-            <a:endParaRPr lang="en-US"/>
           </a:p>
         </p:txBody>
       </p:sp>
@@ -2477,7 +2475,7 @@
           <a:p>
             <a:pPr lvl="0"/>
             <a:r>
-              <a:rPr lang="en-US" smtClean="0"/>
+              <a:rPr lang="en-US"/>
               <a:t>Click to edit Master text styles</a:t>
             </a:r>
           </a:p>
@@ -2501,7 +2499,7 @@
             <a:fld id="{1D8BD707-D9CF-40AE-B4C6-C98DA3205C09}" type="datetimeFigureOut">
               <a:rPr lang="en-US" smtClean="0"/>
               <a:pPr/>
-              <a:t>8/1/2011</a:t>
+              <a:t>4/7/2026</a:t>
             </a:fld>
             <a:endParaRPr lang="en-US"/>
           </a:p>
@@ -2606,10 +2604,9 @@
           <a:lstStyle/>
           <a:p>
             <a:r>
-              <a:rPr lang="en-US" smtClean="0"/>
+              <a:rPr lang="en-US"/>
               <a:t>Click to edit Master title style</a:t>
             </a:r>
-            <a:endParaRPr lang="en-US"/>
           </a:p>
         </p:txBody>
       </p:sp>
@@ -2640,38 +2637,37 @@
           <a:p>
             <a:pPr lvl="0"/>
             <a:r>
-              <a:rPr lang="en-US" smtClean="0"/>
+              <a:rPr lang="en-US"/>
               <a:t>Click to edit Master text styles</a:t>
             </a:r>
           </a:p>
           <a:p>
             <a:pPr lvl="1"/>
             <a:r>
-              <a:rPr lang="en-US" smtClean="0"/>
+              <a:rPr lang="en-US"/>
               <a:t>Second level</a:t>
             </a:r>
           </a:p>
           <a:p>
             <a:pPr lvl="2"/>
             <a:r>
-              <a:rPr lang="en-US" smtClean="0"/>
+              <a:rPr lang="en-US"/>
               <a:t>Third level</a:t>
             </a:r>
           </a:p>
           <a:p>
             <a:pPr lvl="3"/>
             <a:r>
-              <a:rPr lang="en-US" smtClean="0"/>
+              <a:rPr lang="en-US"/>
               <a:t>Fourth level</a:t>
             </a:r>
           </a:p>
           <a:p>
             <a:pPr lvl="4"/>
             <a:r>
-              <a:rPr lang="en-US" smtClean="0"/>
+              <a:rPr lang="en-US"/>
               <a:t>Fifth level</a:t>
             </a:r>
-            <a:endParaRPr lang="en-US"/>
           </a:p>
         </p:txBody>
       </p:sp>
@@ -2711,7 +2707,7 @@
             <a:fld id="{1D8BD707-D9CF-40AE-B4C6-C98DA3205C09}" type="datetimeFigureOut">
               <a:rPr lang="en-US" smtClean="0"/>
               <a:pPr/>
-              <a:t>8/1/2011</a:t>
+              <a:t>4/7/2026</a:t>
             </a:fld>
             <a:endParaRPr lang="en-US"/>
           </a:p>
@@ -3066,13 +3062,14 @@
 </file>
 
 <file path=ppt/slides/slide1.xml><?xml version="1.0" encoding="utf-8"?>
-<p:sld xmlns:p="http://schemas.openxmlformats.org/presentationml/2006/main" xmlns:a="http://schemas.openxmlformats.org/drawingml/2006/main" xmlns:r="http://schemas.openxmlformats.org/officeDocument/2006/relationships">
+<p:sld xmlns:a="http://schemas.openxmlformats.org/drawingml/2006/main" xmlns:r="http://schemas.openxmlformats.org/officeDocument/2006/relationships" xmlns:p="http://schemas.openxmlformats.org/presentationml/2006/main">
   <p:cSld>
     <p:bg>
       <p:bgPr>
         <a:solidFill>
           <a:srgbClr val="D9D9D9"/>
         </a:solidFill>
+        <a:effectLst/>
       </p:bgPr>
     </p:bg>
     <p:spTree>
@@ -3089,14 +3086,50 @@
           <a:chExt cx="0" cy="0"/>
         </a:xfrm>
       </p:grpSpPr>
+      <p:pic>
+        <p:nvPicPr>
+          <p:cNvPr id="17" name="Picture 16">
+            <a:extLst>
+              <a:ext uri="{FF2B5EF4-FFF2-40B4-BE49-F238E27FC236}">
+                <a16:creationId xmlns:a16="http://schemas.microsoft.com/office/drawing/2014/main" id="{61A14184-5AE6-C88E-F49C-78122160F2A7}"/>
+              </a:ext>
+            </a:extLst>
+          </p:cNvPr>
+          <p:cNvPicPr>
+            <a:picLocks noChangeAspect="1"/>
+          </p:cNvPicPr>
+          <p:nvPr/>
+        </p:nvPicPr>
+        <p:blipFill>
+          <a:blip r:embed="rId2">
+            <a:extLst>
+              <a:ext uri="{28A0092B-C50C-407E-A947-70E740481C1C}">
+                <a14:useLocalDpi xmlns:a14="http://schemas.microsoft.com/office/drawing/2010/main" val="0"/>
+              </a:ext>
+            </a:extLst>
+          </a:blip>
+          <a:stretch>
+            <a:fillRect/>
+          </a:stretch>
+        </p:blipFill>
+        <p:spPr>
+          <a:xfrm>
+            <a:off x="13529605" y="233251"/>
+            <a:ext cx="4515480" cy="1590897"/>
+          </a:xfrm>
+          <a:prstGeom prst="rect">
+            <a:avLst/>
+          </a:prstGeom>
+        </p:spPr>
+      </p:pic>
       <p:grpSp>
         <p:nvGrpSpPr>
-          <p:cNvPr name="Group 2" id="2"/>
+          <p:cNvPr id="2" name="Group 2"/>
           <p:cNvGrpSpPr/>
           <p:nvPr/>
         </p:nvGrpSpPr>
         <p:grpSpPr>
-          <a:xfrm rot="0">
+          <a:xfrm>
             <a:off x="-120034" y="1028700"/>
             <a:ext cx="18288000" cy="2964842"/>
             <a:chOff x="0" y="0"/>
@@ -3105,12 +3138,12 @@
         </p:grpSpPr>
         <p:sp>
           <p:nvSpPr>
-            <p:cNvPr name="Freeform 3" id="3"/>
+            <p:cNvPr id="3" name="Freeform 3"/>
             <p:cNvSpPr/>
             <p:nvPr/>
           </p:nvSpPr>
           <p:spPr>
-            <a:xfrm flipH="false" flipV="false" rot="0">
+            <a:xfrm>
               <a:off x="0" y="0"/>
               <a:ext cx="24384000" cy="3953127"/>
             </a:xfrm>
@@ -3119,9 +3152,9 @@
               <a:gdLst/>
               <a:ahLst/>
               <a:cxnLst/>
-              <a:rect r="r" b="b" t="t" l="l"/>
+              <a:rect l="l" t="t" r="r" b="b"/>
               <a:pathLst>
-                <a:path h="3953127" w="24384000">
+                <a:path w="24384000" h="3953127">
                   <a:moveTo>
                     <a:pt x="0" y="0"/>
                   </a:moveTo>
@@ -3139,19 +3172,19 @@
               </a:pathLst>
             </a:custGeom>
             <a:blipFill>
-              <a:blip r:embed="rId2">
+              <a:blip r:embed="rId3">
                 <a:alphaModFix amt="0"/>
               </a:blip>
               <a:stretch>
-                <a:fillRect l="0" t="-77554" r="0" b="-62824"/>
+                <a:fillRect t="-77554" b="-62824"/>
               </a:stretch>
             </a:blipFill>
           </p:spPr>
         </p:sp>
         <p:sp>
           <p:nvSpPr>
-            <p:cNvPr name="TextBox 4" id="4"/>
-            <p:cNvSpPr txBox="true"/>
+            <p:cNvPr id="4" name="TextBox 4"/>
+            <p:cNvSpPr txBox="1"/>
             <p:nvPr/>
           </p:nvSpPr>
           <p:spPr>
@@ -3164,7 +3197,7 @@
             </a:prstGeom>
           </p:spPr>
           <p:txBody>
-            <a:bodyPr anchor="b" rtlCol="false" tIns="0" lIns="0" bIns="0" rIns="0"/>
+            <a:bodyPr lIns="0" tIns="0" rIns="0" bIns="0" rtlCol="0" anchor="b"/>
             <a:lstStyle/>
             <a:p>
               <a:pPr algn="ctr">
@@ -3172,6 +3205,7 @@
                   <a:spcPts val="2916"/>
                 </a:lnSpc>
               </a:pPr>
+              <a:endParaRPr dirty="0"/>
             </a:p>
             <a:p>
               <a:pPr algn="ctr">
@@ -3179,6 +3213,7 @@
                   <a:spcPts val="3936"/>
                 </a:lnSpc>
               </a:pPr>
+              <a:endParaRPr dirty="0"/>
             </a:p>
             <a:p>
               <a:pPr algn="ctr">
@@ -3187,7 +3222,7 @@
                 </a:lnSpc>
               </a:pPr>
               <a:r>
-                <a:rPr lang="en-US" b="true" sz="3645" spc="-22">
+                <a:rPr lang="en-US" sz="3645" b="1" spc="-22" dirty="0">
                   <a:solidFill>
                     <a:srgbClr val="FF0000"/>
                   </a:solidFill>
@@ -3206,7 +3241,7 @@
                 </a:lnSpc>
               </a:pPr>
               <a:r>
-                <a:rPr lang="en-US" b="true" sz="3240" spc="-19">
+                <a:rPr lang="en-US" sz="3240" b="1" spc="-19" dirty="0">
                   <a:solidFill>
                     <a:srgbClr val="FF0000"/>
                   </a:solidFill>
@@ -3225,7 +3260,7 @@
                 </a:lnSpc>
               </a:pPr>
               <a:r>
-                <a:rPr lang="en-US" b="true" sz="3645" spc="-22">
+                <a:rPr lang="en-US" sz="3645" b="1" spc="-22" dirty="0">
                   <a:solidFill>
                     <a:srgbClr val="FF0000"/>
                   </a:solidFill>
@@ -3234,46 +3269,10 @@
                   <a:cs typeface="Aptos Bold"/>
                   <a:sym typeface="Aptos Bold"/>
                 </a:rPr>
-                <a:t>2</a:t>
+                <a:t>2nd International Conference on Communication, Computing and Energy Efficient Technologies (I3CEET-2027</a:t>
               </a:r>
               <a:r>
-                <a:rPr lang="en-US" b="true" sz="3645" spc="-22">
-                  <a:solidFill>
-                    <a:srgbClr val="FF0000"/>
-                  </a:solidFill>
-                  <a:latin typeface="Aptos Bold"/>
-                  <a:ea typeface="Aptos Bold"/>
-                  <a:cs typeface="Aptos Bold"/>
-                  <a:sym typeface="Aptos Bold"/>
-                </a:rPr>
-                <a:t>nd</a:t>
-              </a:r>
-              <a:r>
-                <a:rPr lang="en-US" b="true" sz="3645" spc="-22">
-                  <a:solidFill>
-                    <a:srgbClr val="FF0000"/>
-                  </a:solidFill>
-                  <a:latin typeface="Aptos Bold"/>
-                  <a:ea typeface="Aptos Bold"/>
-                  <a:cs typeface="Aptos Bold"/>
-                  <a:sym typeface="Aptos Bold"/>
-                </a:rPr>
-                <a:t> </a:t>
-              </a:r>
-              <a:r>
-                <a:rPr lang="en-US" b="true" sz="3645" spc="-22">
-                  <a:solidFill>
-                    <a:srgbClr val="FF0000"/>
-                  </a:solidFill>
-                  <a:latin typeface="Aptos Bold"/>
-                  <a:ea typeface="Aptos Bold"/>
-                  <a:cs typeface="Aptos Bold"/>
-                  <a:sym typeface="Aptos Bold"/>
-                </a:rPr>
-                <a:t>International Conference on Computing, Communication and Sustainable Energy Technologies (I3CSET-2026</a:t>
-              </a:r>
-              <a:r>
-                <a:rPr lang="en-US" b="true" sz="3645" i="true" spc="-22">
+                <a:rPr lang="en-US" sz="3645" b="1" i="1" spc="-22" dirty="0">
                   <a:solidFill>
                     <a:srgbClr val="FF0000"/>
                   </a:solidFill>
@@ -3290,12 +3289,12 @@
       </p:grpSp>
       <p:grpSp>
         <p:nvGrpSpPr>
-          <p:cNvPr name="Group 5" id="5"/>
+          <p:cNvPr id="5" name="Group 5"/>
           <p:cNvGrpSpPr/>
           <p:nvPr/>
         </p:nvGrpSpPr>
         <p:grpSpPr>
-          <a:xfrm rot="0">
+          <a:xfrm>
             <a:off x="5006588" y="97107"/>
             <a:ext cx="7315200" cy="1785938"/>
             <a:chOff x="0" y="0"/>
@@ -3304,12 +3303,12 @@
         </p:grpSpPr>
         <p:sp>
           <p:nvSpPr>
-            <p:cNvPr name="Freeform 6" id="6" descr="Galgotias ICACITEE | International Conference on Advance Computing and  Innovative Technologies in Engineering"/>
+            <p:cNvPr id="6" name="Freeform 6" descr="Galgotias ICACITEE | International Conference on Advance Computing and  Innovative Technologies in Engineering"/>
             <p:cNvSpPr/>
             <p:nvPr/>
           </p:nvSpPr>
           <p:spPr>
-            <a:xfrm flipH="false" flipV="false" rot="0">
+            <a:xfrm>
               <a:off x="0" y="0"/>
               <a:ext cx="9753600" cy="2381250"/>
             </a:xfrm>
@@ -3318,9 +3317,9 @@
               <a:gdLst/>
               <a:ahLst/>
               <a:cxnLst/>
-              <a:rect r="r" b="b" t="t" l="l"/>
+              <a:rect l="l" t="t" r="r" b="b"/>
               <a:pathLst>
-                <a:path h="2381250" w="9753600">
+                <a:path w="9753600" h="2381250">
                   <a:moveTo>
                     <a:pt x="0" y="0"/>
                   </a:moveTo>
@@ -3341,153 +3340,31 @@
               </a:pathLst>
             </a:custGeom>
             <a:blipFill>
-              <a:blip r:embed="rId3"/>
+              <a:blip r:embed="rId4"/>
               <a:stretch>
-                <a:fillRect l="0" t="0" r="0" b="0"/>
+                <a:fillRect/>
               </a:stretch>
             </a:blipFill>
           </p:spPr>
         </p:sp>
       </p:grpSp>
-      <p:grpSp>
-        <p:nvGrpSpPr>
-          <p:cNvPr name="Group 7" id="7"/>
-          <p:cNvGrpSpPr/>
+      <p:sp>
+        <p:nvSpPr>
+          <p:cNvPr id="11" name="TextBox 11"/>
+          <p:cNvSpPr txBox="1"/>
           <p:nvPr/>
-        </p:nvGrpSpPr>
-        <p:grpSpPr>
-          <a:xfrm rot="0">
-            <a:off x="518876" y="240506"/>
-            <a:ext cx="2023136" cy="1876619"/>
-            <a:chOff x="0" y="0"/>
-            <a:chExt cx="2567165" cy="2381250"/>
-          </a:xfrm>
-        </p:grpSpPr>
-        <p:sp>
-          <p:nvSpPr>
-            <p:cNvPr name="Freeform 8" id="8"/>
-            <p:cNvSpPr/>
-            <p:nvPr/>
-          </p:nvSpPr>
-          <p:spPr>
-            <a:xfrm flipH="false" flipV="false" rot="0">
-              <a:off x="0" y="0"/>
-              <a:ext cx="2567178" cy="2381250"/>
-            </a:xfrm>
-            <a:custGeom>
-              <a:avLst/>
-              <a:gdLst/>
-              <a:ahLst/>
-              <a:cxnLst/>
-              <a:rect r="r" b="b" t="t" l="l"/>
-              <a:pathLst>
-                <a:path h="2381250" w="2567178">
-                  <a:moveTo>
-                    <a:pt x="0" y="0"/>
-                  </a:moveTo>
-                  <a:lnTo>
-                    <a:pt x="2567178" y="0"/>
-                  </a:lnTo>
-                  <a:lnTo>
-                    <a:pt x="2567178" y="2381250"/>
-                  </a:lnTo>
-                  <a:lnTo>
-                    <a:pt x="0" y="2381250"/>
-                  </a:lnTo>
-                  <a:lnTo>
-                    <a:pt x="0" y="0"/>
-                  </a:lnTo>
-                  <a:close/>
-                </a:path>
-              </a:pathLst>
-            </a:custGeom>
-            <a:blipFill>
-              <a:blip r:embed="rId4"/>
-              <a:stretch>
-                <a:fillRect l="0" t="-3903" r="0" b="-3903"/>
-              </a:stretch>
-            </a:blipFill>
-          </p:spPr>
-        </p:sp>
-      </p:grpSp>
-      <p:grpSp>
-        <p:nvGrpSpPr>
-          <p:cNvPr name="Group 9" id="9"/>
-          <p:cNvGrpSpPr/>
-          <p:nvPr/>
-        </p:nvGrpSpPr>
-        <p:grpSpPr>
-          <a:xfrm rot="0">
-            <a:off x="13748614" y="240506"/>
-            <a:ext cx="4077424" cy="1142790"/>
-            <a:chOff x="0" y="0"/>
-            <a:chExt cx="5436565" cy="1523721"/>
-          </a:xfrm>
-        </p:grpSpPr>
-        <p:sp>
-          <p:nvSpPr>
-            <p:cNvPr name="Freeform 10" id="10" descr="Routledge, Taylor and Francis Group | Society for Research into Higher  Education"/>
-            <p:cNvSpPr/>
-            <p:nvPr/>
-          </p:nvSpPr>
-          <p:spPr>
-            <a:xfrm flipH="false" flipV="false" rot="0">
-              <a:off x="0" y="0"/>
-              <a:ext cx="5436616" cy="1523746"/>
-            </a:xfrm>
-            <a:custGeom>
-              <a:avLst/>
-              <a:gdLst/>
-              <a:ahLst/>
-              <a:cxnLst/>
-              <a:rect r="r" b="b" t="t" l="l"/>
-              <a:pathLst>
-                <a:path h="1523746" w="5436616">
-                  <a:moveTo>
-                    <a:pt x="0" y="0"/>
-                  </a:moveTo>
-                  <a:lnTo>
-                    <a:pt x="5436616" y="0"/>
-                  </a:lnTo>
-                  <a:lnTo>
-                    <a:pt x="5436616" y="1523746"/>
-                  </a:lnTo>
-                  <a:lnTo>
-                    <a:pt x="0" y="1523746"/>
-                  </a:lnTo>
-                  <a:lnTo>
-                    <a:pt x="0" y="0"/>
-                  </a:lnTo>
-                  <a:close/>
-                </a:path>
-              </a:pathLst>
-            </a:custGeom>
-            <a:blipFill>
-              <a:blip r:embed="rId5"/>
-              <a:stretch>
-                <a:fillRect l="0" t="0" r="0" b="1"/>
-              </a:stretch>
-            </a:blipFill>
-          </p:spPr>
-        </p:sp>
-      </p:grpSp>
-      <p:sp>
-        <p:nvSpPr>
-          <p:cNvPr name="TextBox 11" id="11"/>
-          <p:cNvSpPr txBox="true"/>
-          <p:nvPr/>
         </p:nvSpPr>
         <p:spPr>
-          <a:xfrm rot="0">
-            <a:off x="7324287" y="9721567"/>
-            <a:ext cx="3639417" cy="466725"/>
+          <a:xfrm>
+            <a:off x="8077200" y="9754124"/>
+            <a:ext cx="3639417" cy="410369"/>
           </a:xfrm>
           <a:prstGeom prst="rect">
             <a:avLst/>
           </a:prstGeom>
         </p:spPr>
         <p:txBody>
-          <a:bodyPr anchor="t" rtlCol="false" tIns="0" lIns="0" bIns="0" rIns="0">
+          <a:bodyPr lIns="0" tIns="0" rIns="0" bIns="0" rtlCol="0" anchor="t">
             <a:spAutoFit/>
           </a:bodyPr>
           <a:lstStyle/>
@@ -3498,7 +3375,7 @@
               </a:lnSpc>
             </a:pPr>
             <a:r>
-              <a:rPr lang="en-US" sz="2700" b="true">
+              <a:rPr lang="en-US" sz="2700" b="1" dirty="0">
                 <a:solidFill>
                   <a:srgbClr val="000000"/>
                 </a:solidFill>
@@ -3507,67 +3384,19 @@
                 <a:cs typeface="Calibri (MS) Bold"/>
                 <a:sym typeface="Calibri (MS) Bold"/>
               </a:rPr>
-              <a:t>30</a:t>
-            </a:r>
-            <a:r>
-              <a:rPr lang="en-US" sz="2700" b="true">
-                <a:solidFill>
-                  <a:srgbClr val="000000"/>
-                </a:solidFill>
-                <a:latin typeface="Calibri (MS) Bold"/>
-                <a:ea typeface="Calibri (MS) Bold"/>
-                <a:cs typeface="Calibri (MS) Bold"/>
-                <a:sym typeface="Calibri (MS) Bold"/>
-              </a:rPr>
-              <a:t>th</a:t>
-            </a:r>
-            <a:r>
-              <a:rPr lang="en-US" sz="2700" b="true">
-                <a:solidFill>
-                  <a:srgbClr val="000000"/>
-                </a:solidFill>
-                <a:latin typeface="Calibri (MS) Bold"/>
-                <a:ea typeface="Calibri (MS) Bold"/>
-                <a:cs typeface="Calibri (MS) Bold"/>
-                <a:sym typeface="Calibri (MS) Bold"/>
-              </a:rPr>
-              <a:t> Sept &amp; 1</a:t>
-            </a:r>
-            <a:r>
-              <a:rPr lang="en-US" sz="2700" b="true">
-                <a:solidFill>
-                  <a:srgbClr val="000000"/>
-                </a:solidFill>
-                <a:latin typeface="Calibri (MS) Bold"/>
-                <a:ea typeface="Calibri (MS) Bold"/>
-                <a:cs typeface="Calibri (MS) Bold"/>
-                <a:sym typeface="Calibri (MS) Bold"/>
-              </a:rPr>
-              <a:t>st</a:t>
-            </a:r>
-            <a:r>
-              <a:rPr lang="en-US" sz="2700" b="true">
-                <a:solidFill>
-                  <a:srgbClr val="000000"/>
-                </a:solidFill>
-                <a:latin typeface="Calibri (MS) Bold"/>
-                <a:ea typeface="Calibri (MS) Bold"/>
-                <a:cs typeface="Calibri (MS) Bold"/>
-                <a:sym typeface="Calibri (MS) Bold"/>
-              </a:rPr>
-              <a:t> Oct, 2026</a:t>
-            </a:r>
-          </a:p>
-        </p:txBody>
-      </p:sp>
-      <p:sp>
-        <p:nvSpPr>
-          <p:cNvPr name="TextBox 12" id="12"/>
-          <p:cNvSpPr txBox="true"/>
+              <a:t>29-30 April, 2027</a:t>
+            </a:r>
+          </a:p>
+        </p:txBody>
+      </p:sp>
+      <p:sp>
+        <p:nvSpPr>
+          <p:cNvPr id="12" name="TextBox 12"/>
+          <p:cNvSpPr txBox="1"/>
           <p:nvPr/>
         </p:nvSpPr>
         <p:spPr>
-          <a:xfrm rot="0">
+          <a:xfrm>
             <a:off x="-28594" y="3910317"/>
             <a:ext cx="18105120" cy="1856232"/>
           </a:xfrm>
@@ -3576,7 +3405,7 @@
           </a:prstGeom>
         </p:spPr>
         <p:txBody>
-          <a:bodyPr anchor="t" rtlCol="false" tIns="0" lIns="0" bIns="0" rIns="0">
+          <a:bodyPr lIns="0" tIns="0" rIns="0" bIns="0" rtlCol="0" anchor="t">
             <a:spAutoFit/>
           </a:bodyPr>
           <a:lstStyle/>
@@ -3587,7 +3416,7 @@
               </a:lnSpc>
             </a:pPr>
             <a:r>
-              <a:rPr lang="en-US" sz="3600" b="true">
+              <a:rPr lang="en-US" sz="3600" b="1">
                 <a:solidFill>
                   <a:srgbClr val="C00000"/>
                 </a:solidFill>
@@ -3606,7 +3435,7 @@
               </a:lnSpc>
             </a:pPr>
             <a:r>
-              <a:rPr lang="en-US" sz="3600" b="true">
+              <a:rPr lang="en-US" sz="3600" b="1">
                 <a:solidFill>
                   <a:srgbClr val="C00000"/>
                 </a:solidFill>
@@ -3625,7 +3454,7 @@
               </a:lnSpc>
             </a:pPr>
             <a:r>
-              <a:rPr lang="en-US" sz="3600" b="true">
+              <a:rPr lang="en-US" sz="3600" b="1">
                 <a:solidFill>
                   <a:srgbClr val="C00000"/>
                 </a:solidFill>
@@ -3641,12 +3470,12 @@
       </p:sp>
       <p:sp>
         <p:nvSpPr>
-          <p:cNvPr name="TextBox 13" id="13"/>
-          <p:cNvSpPr txBox="true"/>
+          <p:cNvPr id="13" name="TextBox 13"/>
+          <p:cNvSpPr txBox="1"/>
           <p:nvPr/>
         </p:nvSpPr>
         <p:spPr>
-          <a:xfrm rot="0">
+          <a:xfrm>
             <a:off x="6871021" y="6125261"/>
             <a:ext cx="4305891" cy="3209344"/>
           </a:xfrm>
@@ -3655,7 +3484,7 @@
           </a:prstGeom>
         </p:spPr>
         <p:txBody>
-          <a:bodyPr anchor="t" rtlCol="false" tIns="0" lIns="0" bIns="0" rIns="0">
+          <a:bodyPr lIns="0" tIns="0" rIns="0" bIns="0" rtlCol="0" anchor="t">
             <a:spAutoFit/>
           </a:bodyPr>
           <a:lstStyle/>
@@ -3666,7 +3495,7 @@
               </a:lnSpc>
             </a:pPr>
             <a:r>
-              <a:rPr lang="en-US" b="true" sz="4200" i="true">
+              <a:rPr lang="en-US" sz="4200" b="1" i="1">
                 <a:solidFill>
                   <a:srgbClr val="002060"/>
                 </a:solidFill>
@@ -3685,7 +3514,7 @@
               </a:lnSpc>
             </a:pPr>
             <a:r>
-              <a:rPr lang="en-US" b="true" sz="4200" i="true">
+              <a:rPr lang="en-US" sz="4200" b="1" i="1">
                 <a:solidFill>
                   <a:srgbClr val="002060"/>
                 </a:solidFill>
@@ -3704,7 +3533,7 @@
               </a:lnSpc>
             </a:pPr>
             <a:r>
-              <a:rPr lang="en-US" b="true" sz="4200" i="true">
+              <a:rPr lang="en-US" sz="4200" b="1" i="1">
                 <a:solidFill>
                   <a:srgbClr val="002060"/>
                 </a:solidFill>
@@ -3718,6 +3547,42 @@
           </a:p>
         </p:txBody>
       </p:sp>
+      <p:pic>
+        <p:nvPicPr>
+          <p:cNvPr id="19" name="Picture 18">
+            <a:extLst>
+              <a:ext uri="{FF2B5EF4-FFF2-40B4-BE49-F238E27FC236}">
+                <a16:creationId xmlns:a16="http://schemas.microsoft.com/office/drawing/2014/main" id="{1C53497B-FF65-BF79-0365-51184BBBC9F4}"/>
+              </a:ext>
+            </a:extLst>
+          </p:cNvPr>
+          <p:cNvPicPr>
+            <a:picLocks noChangeAspect="1"/>
+          </p:cNvPicPr>
+          <p:nvPr/>
+        </p:nvPicPr>
+        <p:blipFill>
+          <a:blip r:embed="rId5">
+            <a:extLst>
+              <a:ext uri="{28A0092B-C50C-407E-A947-70E740481C1C}">
+                <a14:useLocalDpi xmlns:a14="http://schemas.microsoft.com/office/drawing/2010/main" val="0"/>
+              </a:ext>
+            </a:extLst>
+          </a:blip>
+          <a:stretch>
+            <a:fillRect/>
+          </a:stretch>
+        </p:blipFill>
+        <p:spPr>
+          <a:xfrm>
+            <a:off x="533400" y="109529"/>
+            <a:ext cx="2219009" cy="2214571"/>
+          </a:xfrm>
+          <a:prstGeom prst="rect">
+            <a:avLst/>
+          </a:prstGeom>
+        </p:spPr>
+      </p:pic>
     </p:spTree>
   </p:cSld>
   <p:clrMapOvr>
@@ -3727,13 +3592,14 @@
 </file>
 
 <file path=ppt/slides/slide2.xml><?xml version="1.0" encoding="utf-8"?>
-<p:sld xmlns:p="http://schemas.openxmlformats.org/presentationml/2006/main" xmlns:a="http://schemas.openxmlformats.org/drawingml/2006/main">
+<p:sld xmlns:a="http://schemas.openxmlformats.org/drawingml/2006/main" xmlns:r="http://schemas.openxmlformats.org/officeDocument/2006/relationships" xmlns:p="http://schemas.openxmlformats.org/presentationml/2006/main">
   <p:cSld>
     <p:bg>
       <p:bgPr>
         <a:solidFill>
           <a:srgbClr val="D9D9D9"/>
         </a:solidFill>
+        <a:effectLst/>
       </p:bgPr>
     </p:bg>
     <p:spTree>
@@ -3752,12 +3618,12 @@
       </p:grpSpPr>
       <p:sp>
         <p:nvSpPr>
-          <p:cNvPr name="TextBox 2" id="2"/>
-          <p:cNvSpPr txBox="true"/>
+          <p:cNvPr id="2" name="TextBox 2"/>
+          <p:cNvSpPr txBox="1"/>
           <p:nvPr/>
         </p:nvSpPr>
         <p:spPr>
-          <a:xfrm rot="0">
+          <a:xfrm>
             <a:off x="2060467" y="63741"/>
             <a:ext cx="14535893" cy="9029700"/>
           </a:xfrm>
@@ -3766,7 +3632,7 @@
           </a:prstGeom>
         </p:spPr>
         <p:txBody>
-          <a:bodyPr anchor="t" rtlCol="false" tIns="0" lIns="0" bIns="0" rIns="0">
+          <a:bodyPr lIns="0" tIns="0" rIns="0" bIns="0" rtlCol="0" anchor="t">
             <a:spAutoFit/>
           </a:bodyPr>
           <a:lstStyle/>
@@ -3777,7 +3643,7 @@
               </a:lnSpc>
             </a:pPr>
             <a:r>
-              <a:rPr lang="en-US" sz="4200" b="true">
+              <a:rPr lang="en-US" sz="4200" b="1">
                 <a:solidFill>
                   <a:srgbClr val="002060"/>
                 </a:solidFill>
@@ -3790,7 +3656,7 @@
             </a:r>
           </a:p>
           <a:p>
-            <a:pPr algn="l" marL="651510" indent="-325755" lvl="1">
+            <a:pPr marL="651510" lvl="1" indent="-325755" algn="l">
               <a:lnSpc>
                 <a:spcPts val="8640"/>
               </a:lnSpc>
@@ -3798,7 +3664,7 @@
               <a:buChar char="•"/>
             </a:pPr>
             <a:r>
-              <a:rPr lang="en-US" b="true" sz="3600">
+              <a:rPr lang="en-US" sz="3600" b="1">
                 <a:solidFill>
                   <a:srgbClr val="002060"/>
                 </a:solidFill>
@@ -3811,7 +3677,7 @@
             </a:r>
           </a:p>
           <a:p>
-            <a:pPr algn="l" marL="651510" indent="-325755" lvl="1">
+            <a:pPr marL="651510" lvl="1" indent="-325755" algn="l">
               <a:lnSpc>
                 <a:spcPts val="8640"/>
               </a:lnSpc>
@@ -3819,7 +3685,7 @@
               <a:buChar char="•"/>
             </a:pPr>
             <a:r>
-              <a:rPr lang="en-US" b="true" sz="3600">
+              <a:rPr lang="en-US" sz="3600" b="1">
                 <a:solidFill>
                   <a:srgbClr val="002060"/>
                 </a:solidFill>
@@ -3832,7 +3698,7 @@
             </a:r>
           </a:p>
           <a:p>
-            <a:pPr algn="l" marL="651510" indent="-325755" lvl="1">
+            <a:pPr marL="651510" lvl="1" indent="-325755" algn="l">
               <a:lnSpc>
                 <a:spcPts val="8640"/>
               </a:lnSpc>
@@ -3840,7 +3706,7 @@
               <a:buChar char="•"/>
             </a:pPr>
             <a:r>
-              <a:rPr lang="en-US" b="true" sz="3600">
+              <a:rPr lang="en-US" sz="3600" b="1">
                 <a:solidFill>
                   <a:srgbClr val="002060"/>
                 </a:solidFill>
@@ -3853,7 +3719,7 @@
             </a:r>
           </a:p>
           <a:p>
-            <a:pPr algn="l" marL="651510" indent="-325755" lvl="1">
+            <a:pPr marL="651510" lvl="1" indent="-325755" algn="l">
               <a:lnSpc>
                 <a:spcPts val="8640"/>
               </a:lnSpc>
@@ -3861,7 +3727,7 @@
               <a:buChar char="•"/>
             </a:pPr>
             <a:r>
-              <a:rPr lang="en-US" b="true" sz="3600">
+              <a:rPr lang="en-US" sz="3600" b="1">
                 <a:solidFill>
                   <a:srgbClr val="002060"/>
                 </a:solidFill>
@@ -3874,7 +3740,7 @@
             </a:r>
           </a:p>
           <a:p>
-            <a:pPr algn="l" marL="651510" indent="-325755" lvl="1">
+            <a:pPr marL="651510" lvl="1" indent="-325755" algn="l">
               <a:lnSpc>
                 <a:spcPts val="8640"/>
               </a:lnSpc>
@@ -3882,7 +3748,7 @@
               <a:buChar char="•"/>
             </a:pPr>
             <a:r>
-              <a:rPr lang="en-US" b="true" sz="3600">
+              <a:rPr lang="en-US" sz="3600" b="1">
                 <a:solidFill>
                   <a:srgbClr val="002060"/>
                 </a:solidFill>
@@ -3895,7 +3761,7 @@
             </a:r>
           </a:p>
           <a:p>
-            <a:pPr algn="l" marL="651510" indent="-325755" lvl="1">
+            <a:pPr marL="651510" lvl="1" indent="-325755" algn="l">
               <a:lnSpc>
                 <a:spcPts val="8640"/>
               </a:lnSpc>
@@ -3903,7 +3769,7 @@
               <a:buChar char="•"/>
             </a:pPr>
             <a:r>
-              <a:rPr lang="en-US" b="true" sz="3600">
+              <a:rPr lang="en-US" sz="3600" b="1">
                 <a:solidFill>
                   <a:srgbClr val="002060"/>
                 </a:solidFill>
@@ -3916,7 +3782,7 @@
             </a:r>
           </a:p>
           <a:p>
-            <a:pPr algn="l" marL="651510" indent="-325755" lvl="1">
+            <a:pPr marL="651510" lvl="1" indent="-325755" algn="l">
               <a:lnSpc>
                 <a:spcPts val="8640"/>
               </a:lnSpc>
@@ -3924,7 +3790,7 @@
               <a:buChar char="•"/>
             </a:pPr>
             <a:r>
-              <a:rPr lang="en-US" b="true" sz="3600">
+              <a:rPr lang="en-US" sz="3600" b="1">
                 <a:solidFill>
                   <a:srgbClr val="002060"/>
                 </a:solidFill>

</xml_diff>

<commit_message>
Update presentation slides resource
</commit_message>
<xml_diff>
--- a/resources/presentation_slide.pptx
+++ b/resources/presentation_slide.pptx
@@ -327,7 +327,7 @@
             <a:fld id="{1D8BD707-D9CF-40AE-B4C6-C98DA3205C09}" type="datetimeFigureOut">
               <a:rPr lang="en-US" smtClean="0"/>
               <a:pPr/>
-              <a:t>4/7/2026</a:t>
+              <a:t>4/15/2026</a:t>
             </a:fld>
             <a:endParaRPr lang="en-US"/>
           </a:p>
@@ -492,7 +492,7 @@
             <a:fld id="{1D8BD707-D9CF-40AE-B4C6-C98DA3205C09}" type="datetimeFigureOut">
               <a:rPr lang="en-US" smtClean="0"/>
               <a:pPr/>
-              <a:t>4/7/2026</a:t>
+              <a:t>4/15/2026</a:t>
             </a:fld>
             <a:endParaRPr lang="en-US"/>
           </a:p>
@@ -667,7 +667,7 @@
             <a:fld id="{1D8BD707-D9CF-40AE-B4C6-C98DA3205C09}" type="datetimeFigureOut">
               <a:rPr lang="en-US" smtClean="0"/>
               <a:pPr/>
-              <a:t>4/7/2026</a:t>
+              <a:t>4/15/2026</a:t>
             </a:fld>
             <a:endParaRPr lang="en-US"/>
           </a:p>
@@ -832,7 +832,7 @@
             <a:fld id="{1D8BD707-D9CF-40AE-B4C6-C98DA3205C09}" type="datetimeFigureOut">
               <a:rPr lang="en-US" smtClean="0"/>
               <a:pPr/>
-              <a:t>4/7/2026</a:t>
+              <a:t>4/15/2026</a:t>
             </a:fld>
             <a:endParaRPr lang="en-US"/>
           </a:p>
@@ -1074,7 +1074,7 @@
             <a:fld id="{1D8BD707-D9CF-40AE-B4C6-C98DA3205C09}" type="datetimeFigureOut">
               <a:rPr lang="en-US" smtClean="0"/>
               <a:pPr/>
-              <a:t>4/7/2026</a:t>
+              <a:t>4/15/2026</a:t>
             </a:fld>
             <a:endParaRPr lang="en-US"/>
           </a:p>
@@ -1356,7 +1356,7 @@
             <a:fld id="{1D8BD707-D9CF-40AE-B4C6-C98DA3205C09}" type="datetimeFigureOut">
               <a:rPr lang="en-US" smtClean="0"/>
               <a:pPr/>
-              <a:t>4/7/2026</a:t>
+              <a:t>4/15/2026</a:t>
             </a:fld>
             <a:endParaRPr lang="en-US"/>
           </a:p>
@@ -1772,7 +1772,7 @@
             <a:fld id="{1D8BD707-D9CF-40AE-B4C6-C98DA3205C09}" type="datetimeFigureOut">
               <a:rPr lang="en-US" smtClean="0"/>
               <a:pPr/>
-              <a:t>4/7/2026</a:t>
+              <a:t>4/15/2026</a:t>
             </a:fld>
             <a:endParaRPr lang="en-US"/>
           </a:p>
@@ -1886,7 +1886,7 @@
             <a:fld id="{1D8BD707-D9CF-40AE-B4C6-C98DA3205C09}" type="datetimeFigureOut">
               <a:rPr lang="en-US" smtClean="0"/>
               <a:pPr/>
-              <a:t>4/7/2026</a:t>
+              <a:t>4/15/2026</a:t>
             </a:fld>
             <a:endParaRPr lang="en-US"/>
           </a:p>
@@ -1978,7 +1978,7 @@
             <a:fld id="{1D8BD707-D9CF-40AE-B4C6-C98DA3205C09}" type="datetimeFigureOut">
               <a:rPr lang="en-US" smtClean="0"/>
               <a:pPr/>
-              <a:t>4/7/2026</a:t>
+              <a:t>4/15/2026</a:t>
             </a:fld>
             <a:endParaRPr lang="en-US"/>
           </a:p>
@@ -2250,7 +2250,7 @@
             <a:fld id="{1D8BD707-D9CF-40AE-B4C6-C98DA3205C09}" type="datetimeFigureOut">
               <a:rPr lang="en-US" smtClean="0"/>
               <a:pPr/>
-              <a:t>4/7/2026</a:t>
+              <a:t>4/15/2026</a:t>
             </a:fld>
             <a:endParaRPr lang="en-US"/>
           </a:p>
@@ -2499,7 +2499,7 @@
             <a:fld id="{1D8BD707-D9CF-40AE-B4C6-C98DA3205C09}" type="datetimeFigureOut">
               <a:rPr lang="en-US" smtClean="0"/>
               <a:pPr/>
-              <a:t>4/7/2026</a:t>
+              <a:t>4/15/2026</a:t>
             </a:fld>
             <a:endParaRPr lang="en-US"/>
           </a:p>
@@ -2707,7 +2707,7 @@
             <a:fld id="{1D8BD707-D9CF-40AE-B4C6-C98DA3205C09}" type="datetimeFigureOut">
               <a:rPr lang="en-US" smtClean="0"/>
               <a:pPr/>
-              <a:t>4/7/2026</a:t>
+              <a:t>4/15/2026</a:t>
             </a:fld>
             <a:endParaRPr lang="en-US"/>
           </a:p>
@@ -3130,7 +3130,7 @@
         </p:nvGrpSpPr>
         <p:grpSpPr>
           <a:xfrm>
-            <a:off x="-120034" y="1028700"/>
+            <a:off x="-120034" y="1494107"/>
             <a:ext cx="18288000" cy="2964842"/>
             <a:chOff x="0" y="0"/>
             <a:chExt cx="24384000" cy="3953123"/>
@@ -3284,6 +3284,25 @@
                 <a:t>)</a:t>
               </a:r>
             </a:p>
+            <a:p>
+              <a:pPr algn="ctr">
+                <a:lnSpc>
+                  <a:spcPts val="3936"/>
+                </a:lnSpc>
+              </a:pPr>
+              <a:r>
+                <a:rPr lang="en-US" sz="3645" b="1" i="1" spc="-22" dirty="0">
+                  <a:solidFill>
+                    <a:srgbClr val="FF0000"/>
+                  </a:solidFill>
+                  <a:latin typeface="Aptos Bold Italics"/>
+                  <a:ea typeface="Aptos Bold Italics"/>
+                  <a:cs typeface="Aptos Bold Italics"/>
+                  <a:sym typeface="Aptos Bold Italics"/>
+                </a:rPr>
+                <a:t>Conference ID: 72204</a:t>
+              </a:r>
+            </a:p>
           </p:txBody>
         </p:sp>
       </p:grpSp>
@@ -3356,7 +3375,7 @@
         </p:nvSpPr>
         <p:spPr>
           <a:xfrm>
-            <a:off x="8077200" y="9754124"/>
+            <a:off x="8077200" y="9715500"/>
             <a:ext cx="3639417" cy="410369"/>
           </a:xfrm>
           <a:prstGeom prst="rect">
@@ -3397,7 +3416,7 @@
         </p:nvSpPr>
         <p:spPr>
           <a:xfrm>
-            <a:off x="-28594" y="3910317"/>
+            <a:off x="-28594" y="4375724"/>
             <a:ext cx="18105120" cy="1856232"/>
           </a:xfrm>
           <a:prstGeom prst="rect">
@@ -3416,7 +3435,7 @@
               </a:lnSpc>
             </a:pPr>
             <a:r>
-              <a:rPr lang="en-US" sz="3600" b="1">
+              <a:rPr lang="en-US" sz="3600" b="1" dirty="0">
                 <a:solidFill>
                   <a:srgbClr val="C00000"/>
                 </a:solidFill>
@@ -3435,7 +3454,7 @@
               </a:lnSpc>
             </a:pPr>
             <a:r>
-              <a:rPr lang="en-US" sz="3600" b="1">
+              <a:rPr lang="en-US" sz="3600" b="1" dirty="0">
                 <a:solidFill>
                   <a:srgbClr val="C00000"/>
                 </a:solidFill>
@@ -3454,7 +3473,7 @@
               </a:lnSpc>
             </a:pPr>
             <a:r>
-              <a:rPr lang="en-US" sz="3600" b="1">
+              <a:rPr lang="en-US" sz="3600" b="1" dirty="0">
                 <a:solidFill>
                   <a:srgbClr val="C00000"/>
                 </a:solidFill>
@@ -3476,7 +3495,7 @@
         </p:nvSpPr>
         <p:spPr>
           <a:xfrm>
-            <a:off x="6871021" y="6125261"/>
+            <a:off x="6871021" y="6590668"/>
             <a:ext cx="4305891" cy="3209344"/>
           </a:xfrm>
           <a:prstGeom prst="rect">
@@ -3495,7 +3514,7 @@
               </a:lnSpc>
             </a:pPr>
             <a:r>
-              <a:rPr lang="en-US" sz="4200" b="1" i="1">
+              <a:rPr lang="en-US" sz="4200" b="1" i="1" dirty="0">
                 <a:solidFill>
                   <a:srgbClr val="002060"/>
                 </a:solidFill>
@@ -3514,7 +3533,7 @@
               </a:lnSpc>
             </a:pPr>
             <a:r>
-              <a:rPr lang="en-US" sz="4200" b="1" i="1">
+              <a:rPr lang="en-US" sz="4200" b="1" i="1" dirty="0">
                 <a:solidFill>
                   <a:srgbClr val="002060"/>
                 </a:solidFill>
@@ -3533,7 +3552,7 @@
               </a:lnSpc>
             </a:pPr>
             <a:r>
-              <a:rPr lang="en-US" sz="4200" b="1" i="1">
+              <a:rPr lang="en-US" sz="4200" b="1" i="1" dirty="0">
                 <a:solidFill>
                   <a:srgbClr val="002060"/>
                 </a:solidFill>
@@ -3562,21 +3581,20 @@
           <p:nvPr/>
         </p:nvPicPr>
         <p:blipFill>
-          <a:blip r:embed="rId5">
+          <a:blip r:embed="rId5" cstate="print">
             <a:extLst>
               <a:ext uri="{28A0092B-C50C-407E-A947-70E740481C1C}">
                 <a14:useLocalDpi xmlns:a14="http://schemas.microsoft.com/office/drawing/2010/main" val="0"/>
               </a:ext>
             </a:extLst>
           </a:blip>
-          <a:stretch>
-            <a:fillRect/>
-          </a:stretch>
+          <a:srcRect/>
+          <a:stretch/>
         </p:blipFill>
         <p:spPr>
           <a:xfrm>
-            <a:off x="533400" y="109529"/>
-            <a:ext cx="2219009" cy="2214571"/>
+            <a:off x="535619" y="109529"/>
+            <a:ext cx="2214571" cy="2214571"/>
           </a:xfrm>
           <a:prstGeom prst="rect">
             <a:avLst/>

</xml_diff>